<commit_message>
minor updates to networking slides
</commit_message>
<xml_diff>
--- a/Intro to Computers/Lesson 02 - Networking Basics/Lesson 2 - Network Basics.pptx
+++ b/Intro to Computers/Lesson 02 - Networking Basics/Lesson 2 - Network Basics.pptx
@@ -984,6 +984,75 @@
 </p:notes>
 </file>
 
+<file path=ppt/notesSlides/notesSlide5.xml><?xml version="1.0" encoding="utf-8"?>
+<p:notes xmlns:a="http://schemas.openxmlformats.org/drawingml/2006/main" xmlns:r="http://schemas.openxmlformats.org/officeDocument/2006/relationships" xmlns:p="http://schemas.openxmlformats.org/presentationml/2006/main">
+  <p:cSld>
+    <p:spTree>
+      <p:nvGrpSpPr>
+        <p:cNvPr id="1" name=""/>
+        <p:cNvGrpSpPr/>
+        <p:nvPr/>
+      </p:nvGrpSpPr>
+      <p:grpSpPr>
+        <a:xfrm>
+          <a:off x="0" y="0"/>
+          <a:ext cx="0" cy="0"/>
+          <a:chOff x="0" y="0"/>
+          <a:chExt cx="0" cy="0"/>
+        </a:xfrm>
+      </p:grpSpPr>
+      <p:sp>
+        <p:nvSpPr>
+          <p:cNvPr id="2" name="Slide Image Placeholder 1"/>
+          <p:cNvSpPr>
+            <a:spLocks noGrp="1" noRot="1" noChangeAspect="1"/>
+          </p:cNvSpPr>
+          <p:nvPr>
+            <p:ph type="sldImg"/>
+          </p:nvPr>
+        </p:nvSpPr>
+        <p:spPr>
+          <a:xfrm>
+            <a:off x="381000" y="685800"/>
+            <a:ext cx="6096000" cy="3429000"/>
+          </a:xfrm>
+        </p:spPr>
+      </p:sp>
+      <p:sp>
+        <p:nvSpPr>
+          <p:cNvPr id="3" name="Notes Placeholder 2"/>
+          <p:cNvSpPr>
+            <a:spLocks noGrp="1"/>
+          </p:cNvSpPr>
+          <p:nvPr>
+            <p:ph type="body" idx="1"/>
+          </p:nvPr>
+        </p:nvSpPr>
+        <p:spPr/>
+        <p:txBody>
+          <a:bodyPr/>
+          <a:lstStyle/>
+          <a:p>
+            <a:r>
+              <a:rPr lang="en-US" dirty="0"/>
+              <a:t>In the cloud lessons, you’ll see how crazy the port mappings can get.</a:t>
+            </a:r>
+          </a:p>
+        </p:txBody>
+      </p:sp>
+    </p:spTree>
+    <p:extLst>
+      <p:ext uri="{BB962C8B-B14F-4D97-AF65-F5344CB8AC3E}">
+        <p14:creationId xmlns:p14="http://schemas.microsoft.com/office/powerpoint/2010/main" val="1981713716"/>
+      </p:ext>
+    </p:extLst>
+  </p:cSld>
+  <p:clrMapOvr>
+    <a:masterClrMapping/>
+  </p:clrMapOvr>
+</p:notes>
+</file>
+
 <file path=ppt/slideLayouts/slideLayout1.xml><?xml version="1.0" encoding="utf-8"?>
 <p:sldLayout xmlns:a="http://schemas.openxmlformats.org/drawingml/2006/main" xmlns:r="http://schemas.openxmlformats.org/officeDocument/2006/relationships" xmlns:p="http://schemas.openxmlformats.org/presentationml/2006/main" showMasterSp="0" preserve="1">
   <p:cSld name="Title Slide">
@@ -24834,6 +24903,21 @@
             <a:pPr lvl="1"/>
             <a:r>
               <a:rPr lang="en-US" dirty="0"/>
+              <a:t>Connect to some other </a:t>
+            </a:r>
+            <a:r>
+              <a:rPr lang="en-US" dirty="0" err="1">
+                <a:latin typeface="Courier New" panose="02070309020205020404" pitchFamily="49" charset="0"/>
+                <a:cs typeface="Courier New" panose="02070309020205020404" pitchFamily="49" charset="0"/>
+              </a:rPr>
+              <a:t>interface:port</a:t>
+            </a:r>
+            <a:endParaRPr lang="en-US" dirty="0"/>
+          </a:p>
+          <a:p>
+            <a:pPr lvl="1"/>
+            <a:r>
+              <a:rPr lang="en-US" dirty="0"/>
               <a:t>Use that </a:t>
             </a:r>
             <a:r>
@@ -27797,13 +27881,54 @@
             <a:endParaRPr lang="en-US" dirty="0"/>
           </a:p>
           <a:p>
+            <a:pPr marL="137160" lvl="1" indent="0">
+              <a:buNone/>
+            </a:pPr>
             <a:r>
               <a:rPr lang="en-US" dirty="0"/>
-              <a:t>🚨 (Light MATH warning) 🚨</a:t>
-            </a:r>
-          </a:p>
-          <a:p>
+              <a:t>(Light MATH warning)</a:t>
+            </a:r>
+          </a:p>
+          <a:p>
+            <a:pPr marL="0" indent="0">
+              <a:buNone/>
+            </a:pPr>
             <a:endParaRPr lang="en-US" dirty="0"/>
+          </a:p>
+        </p:txBody>
+      </p:sp>
+      <p:sp>
+        <p:nvSpPr>
+          <p:cNvPr id="7" name="TextBox 6">
+            <a:extLst>
+              <a:ext uri="{FF2B5EF4-FFF2-40B4-BE49-F238E27FC236}">
+                <a16:creationId xmlns:a16="http://schemas.microsoft.com/office/drawing/2014/main" id="{601884EE-75F2-B6C6-6EDA-69AD9FF7AE5E}"/>
+              </a:ext>
+            </a:extLst>
+          </p:cNvPr>
+          <p:cNvSpPr txBox="1"/>
+          <p:nvPr/>
+        </p:nvSpPr>
+        <p:spPr>
+          <a:xfrm>
+            <a:off x="200556" y="3347581"/>
+            <a:ext cx="2275490" cy="307777"/>
+          </a:xfrm>
+          <a:prstGeom prst="rect">
+            <a:avLst/>
+          </a:prstGeom>
+          <a:noFill/>
+        </p:spPr>
+        <p:txBody>
+          <a:bodyPr wrap="square">
+            <a:spAutoFit/>
+          </a:bodyPr>
+          <a:lstStyle/>
+          <a:p>
+            <a:r>
+              <a:rPr lang="en-US" dirty="0"/>
+              <a:t>🚨		🚨</a:t>
+            </a:r>
           </a:p>
         </p:txBody>
       </p:sp>
@@ -27829,6 +27954,9 @@
                     <p:cTn id="3" fill="hold">
                       <p:stCondLst>
                         <p:cond delay="indefinite"/>
+                        <p:cond evt="onBegin" delay="0">
+                          <p:tn val="2"/>
+                        </p:cond>
                       </p:stCondLst>
                       <p:childTnLst>
                         <p:par>
@@ -27838,7 +27966,7 @@
                             </p:stCondLst>
                             <p:childTnLst>
                               <p:par>
-                                <p:cTn id="5" presetID="1" presetClass="entr" presetSubtype="0" fill="hold" nodeType="clickEffect">
+                                <p:cTn id="5" presetID="1" presetClass="entr" presetSubtype="0" fill="hold" grpId="0" nodeType="withEffect">
                                   <p:stCondLst>
                                     <p:cond delay="0"/>
                                   </p:stCondLst>
@@ -27846,6 +27974,117 @@
                                     <p:set>
                                       <p:cBhvr>
                                         <p:cTn id="6" dur="1" fill="hold">
+                                          <p:stCondLst>
+                                            <p:cond delay="0"/>
+                                          </p:stCondLst>
+                                        </p:cTn>
+                                        <p:tgtEl>
+                                          <p:spTgt spid="7"/>
+                                        </p:tgtEl>
+                                        <p:attrNameLst>
+                                          <p:attrName>style.visibility</p:attrName>
+                                        </p:attrNameLst>
+                                      </p:cBhvr>
+                                      <p:to>
+                                        <p:strVal val="visible"/>
+                                      </p:to>
+                                    </p:set>
+                                  </p:childTnLst>
+                                </p:cTn>
+                              </p:par>
+                              <p:par>
+                                <p:cTn id="7" presetID="32" presetClass="emph" presetSubtype="0" repeatCount="indefinite" fill="hold" grpId="1" nodeType="withEffect">
+                                  <p:stCondLst>
+                                    <p:cond delay="0"/>
+                                  </p:stCondLst>
+                                  <p:childTnLst>
+                                    <p:animRot by="120000">
+                                      <p:cBhvr>
+                                        <p:cTn id="8" dur="100" fill="hold">
+                                          <p:stCondLst>
+                                            <p:cond delay="0"/>
+                                          </p:stCondLst>
+                                        </p:cTn>
+                                        <p:tgtEl>
+                                          <p:spTgt spid="7"/>
+                                        </p:tgtEl>
+                                        <p:attrNameLst>
+                                          <p:attrName>r</p:attrName>
+                                        </p:attrNameLst>
+                                      </p:cBhvr>
+                                    </p:animRot>
+                                    <p:animRot by="-240000">
+                                      <p:cBhvr>
+                                        <p:cTn id="9" dur="200" fill="hold">
+                                          <p:stCondLst>
+                                            <p:cond delay="200"/>
+                                          </p:stCondLst>
+                                        </p:cTn>
+                                        <p:tgtEl>
+                                          <p:spTgt spid="7"/>
+                                        </p:tgtEl>
+                                        <p:attrNameLst>
+                                          <p:attrName>r</p:attrName>
+                                        </p:attrNameLst>
+                                      </p:cBhvr>
+                                    </p:animRot>
+                                    <p:animRot by="240000">
+                                      <p:cBhvr>
+                                        <p:cTn id="10" dur="200" fill="hold">
+                                          <p:stCondLst>
+                                            <p:cond delay="400"/>
+                                          </p:stCondLst>
+                                        </p:cTn>
+                                        <p:tgtEl>
+                                          <p:spTgt spid="7"/>
+                                        </p:tgtEl>
+                                        <p:attrNameLst>
+                                          <p:attrName>r</p:attrName>
+                                        </p:attrNameLst>
+                                      </p:cBhvr>
+                                    </p:animRot>
+                                    <p:animRot by="-240000">
+                                      <p:cBhvr>
+                                        <p:cTn id="11" dur="200" fill="hold">
+                                          <p:stCondLst>
+                                            <p:cond delay="600"/>
+                                          </p:stCondLst>
+                                        </p:cTn>
+                                        <p:tgtEl>
+                                          <p:spTgt spid="7"/>
+                                        </p:tgtEl>
+                                        <p:attrNameLst>
+                                          <p:attrName>r</p:attrName>
+                                        </p:attrNameLst>
+                                      </p:cBhvr>
+                                    </p:animRot>
+                                    <p:animRot by="120000">
+                                      <p:cBhvr>
+                                        <p:cTn id="12" dur="200" fill="hold">
+                                          <p:stCondLst>
+                                            <p:cond delay="800"/>
+                                          </p:stCondLst>
+                                        </p:cTn>
+                                        <p:tgtEl>
+                                          <p:spTgt spid="7"/>
+                                        </p:tgtEl>
+                                        <p:attrNameLst>
+                                          <p:attrName>r</p:attrName>
+                                        </p:attrNameLst>
+                                      </p:cBhvr>
+                                    </p:animRot>
+                                  </p:childTnLst>
+                                </p:cTn>
+                              </p:par>
+                              <p:par>
+                                <p:cTn id="13" presetID="1" presetClass="entr" presetSubtype="0" fill="hold" nodeType="withEffect">
+                                  <p:stCondLst>
+                                    <p:cond delay="0"/>
+                                  </p:stCondLst>
+                                  <p:childTnLst>
+                                    <p:set>
+                                      <p:cBhvr>
+                                        <p:cTn id="14" dur="1" fill="hold">
                                           <p:stCondLst>
                                             <p:cond delay="0"/>
                                           </p:stCondLst>
@@ -27895,6 +28134,10 @@
         </p:cTn>
       </p:par>
     </p:tnLst>
+    <p:bldLst>
+      <p:bldP spid="7" grpId="0"/>
+      <p:bldP spid="7" grpId="1"/>
+    </p:bldLst>
   </p:timing>
 </p:sld>
 </file>
@@ -28597,15 +28840,30 @@
           <a:p>
             <a:pPr lvl="1"/>
             <a:r>
+              <a:rPr lang="en-US" dirty="0">
+                <a:highlight>
+                  <a:srgbClr val="FFFF00"/>
+                </a:highlight>
+              </a:rPr>
+              <a:t>Multiplexing</a:t>
+            </a:r>
+          </a:p>
+          <a:p>
+            <a:pPr lvl="1"/>
+            <a:r>
+              <a:rPr lang="en-US" dirty="0">
+                <a:highlight>
+                  <a:srgbClr val="FFFF00"/>
+                </a:highlight>
+              </a:rPr>
+              <a:t>Addressing</a:t>
+            </a:r>
+          </a:p>
+          <a:p>
+            <a:pPr lvl="1"/>
+            <a:r>
               <a:rPr lang="en-US" dirty="0"/>
-              <a:t>Multiplexing</a:t>
-            </a:r>
-          </a:p>
-          <a:p>
-            <a:pPr lvl="1"/>
-            <a:r>
-              <a:rPr lang="en-US" dirty="0"/>
-              <a:t>Addressing</a:t>
+              <a:t>Reliability</a:t>
             </a:r>
           </a:p>
           <a:p>
@@ -28950,6 +29208,37 @@
                                           <p:spTgt spid="3">
                                             <p:txEl>
                                               <p:pRg st="10" end="10"/>
+                                            </p:txEl>
+                                          </p:spTgt>
+                                        </p:tgtEl>
+                                        <p:attrNameLst>
+                                          <p:attrName>style.visibility</p:attrName>
+                                        </p:attrNameLst>
+                                      </p:cBhvr>
+                                      <p:to>
+                                        <p:strVal val="visible"/>
+                                      </p:to>
+                                    </p:set>
+                                  </p:childTnLst>
+                                </p:cTn>
+                              </p:par>
+                              <p:par>
+                                <p:cTn id="17" presetID="1" presetClass="entr" presetSubtype="0" fill="hold" nodeType="withEffect">
+                                  <p:stCondLst>
+                                    <p:cond delay="0"/>
+                                  </p:stCondLst>
+                                  <p:childTnLst>
+                                    <p:set>
+                                      <p:cBhvr>
+                                        <p:cTn id="18" dur="1" fill="hold">
+                                          <p:stCondLst>
+                                            <p:cond delay="0"/>
+                                          </p:stCondLst>
+                                        </p:cTn>
+                                        <p:tgtEl>
+                                          <p:spTgt spid="3">
+                                            <p:txEl>
+                                              <p:pRg st="11" end="11"/>
                                             </p:txEl>
                                           </p:spTgt>
                                         </p:tgtEl>

</xml_diff>